<commit_message>
Sync thesis experiment updates
</commit_message>
<xml_diff>
--- a/ls/llm-testing-fault-localization-defense-methodology-focus-with-speaker-notes.pptx
+++ b/ls/llm-testing-fault-localization-defense-methodology-focus-with-speaker-notes.pptx
@@ -345,7 +345,7 @@
           <a:p>
             <a:r>
               <a:rPr lang="en-US" sz="1200" dirty="0"/>
-              <a:t>Good morning everyone. My name is Ziniu Jin, and today I’m going to present my literature study.</a:t>
+              <a:t>Good afternoon everyone. My name is Ziniu Jin, and today I’m going to present my literature study.</a:t>
             </a:r>
           </a:p>
           <a:p>
@@ -15476,22 +15476,22 @@
       </p:sp>
       <p:sp>
         <p:nvSpPr>
-          <p:cNvPr id="23" name="矩形 22">
-            <a:extLst>
-              <a:ext uri="{FF2B5EF4-FFF2-40B4-BE49-F238E27FC236}">
-                <a16:creationId xmlns:a16="http://schemas.microsoft.com/office/drawing/2014/main" id="{677FF4C4-4ADA-43FA-B938-D2B4F560FC21}"/>
-              </a:ext>
-            </a:extLst>
-          </p:cNvPr>
-          <p:cNvSpPr>
-            <a:spLocks noGrp="1"/>
-          </p:cNvSpPr>
-          <p:nvPr/>
-        </p:nvSpPr>
-        <p:spPr>
-          <a:xfrm>
-            <a:off x="1752600" y="5391150"/>
-            <a:ext cx="1238250" cy="171450"/>
+          <p:cNvPr id="24" name="矩形 23">
+            <a:extLst>
+              <a:ext uri="{FF2B5EF4-FFF2-40B4-BE49-F238E27FC236}">
+                <a16:creationId xmlns:a16="http://schemas.microsoft.com/office/drawing/2014/main" id="{631059AB-410F-477D-BAC1-8F240881110E}"/>
+              </a:ext>
+            </a:extLst>
+          </p:cNvPr>
+          <p:cNvSpPr>
+            <a:spLocks noGrp="1"/>
+          </p:cNvSpPr>
+          <p:nvPr/>
+        </p:nvSpPr>
+        <p:spPr>
+          <a:xfrm>
+            <a:off x="3028950" y="5353050"/>
+            <a:ext cx="6858000" cy="247650"/>
           </a:xfrm>
           <a:prstGeom prst="rect">
             <a:avLst/>
@@ -15515,70 +15515,6 @@
           <a:lstStyle/>
           <a:p>
             <a:pPr algn="l">
-              <a:defRPr sz="1050" b="1">
-                <a:solidFill>
-                  <a:srgbClr val="1F2328"/>
-                </a:solidFill>
-                <a:latin typeface="Aptos"/>
-                <a:ea typeface="Aptos"/>
-                <a:cs typeface="Aptos"/>
-              </a:defRPr>
-            </a:pPr>
-            <a:r>
-              <a:rPr sz="1050" b="1">
-                <a:solidFill>
-                  <a:srgbClr val="1F2328"/>
-                </a:solidFill>
-                <a:latin typeface="Aptos"/>
-                <a:ea typeface="Aptos"/>
-                <a:cs typeface="Aptos"/>
-              </a:rPr>
-              <a:t>Speaking point</a:t>
-            </a:r>
-          </a:p>
-        </p:txBody>
-      </p:sp>
-      <p:sp>
-        <p:nvSpPr>
-          <p:cNvPr id="24" name="矩形 23">
-            <a:extLst>
-              <a:ext uri="{FF2B5EF4-FFF2-40B4-BE49-F238E27FC236}">
-                <a16:creationId xmlns:a16="http://schemas.microsoft.com/office/drawing/2014/main" id="{631059AB-410F-477D-BAC1-8F240881110E}"/>
-              </a:ext>
-            </a:extLst>
-          </p:cNvPr>
-          <p:cNvSpPr>
-            <a:spLocks noGrp="1"/>
-          </p:cNvSpPr>
-          <p:nvPr/>
-        </p:nvSpPr>
-        <p:spPr>
-          <a:xfrm>
-            <a:off x="3028950" y="5353050"/>
-            <a:ext cx="6858000" cy="247650"/>
-          </a:xfrm>
-          <a:prstGeom prst="rect">
-            <a:avLst/>
-          </a:prstGeom>
-          <a:solidFill>
-            <a:srgbClr val="000000">
-              <a:alpha val="0"/>
-            </a:srgbClr>
-          </a:solidFill>
-          <a:ln w="0">
-            <a:solidFill>
-              <a:srgbClr val="000000">
-                <a:alpha val="0"/>
-              </a:srgbClr>
-            </a:solidFill>
-            <a:prstDash val="solid"/>
-          </a:ln>
-        </p:spPr>
-        <p:txBody>
-          <a:bodyPr lIns="0" tIns="0" rIns="0" bIns="0" anchor="t"/>
-          <a:lstStyle/>
-          <a:p>
-            <a:pPr algn="l">
               <a:defRPr sz="1200" b="0">
                 <a:solidFill>
                   <a:srgbClr val="5D625F"/>
@@ -15589,7 +15525,7 @@
               </a:defRPr>
             </a:pPr>
             <a:r>
-              <a:rPr sz="1200" b="0">
+              <a:rPr sz="1200" b="0" dirty="0">
                 <a:solidFill>
                   <a:srgbClr val="5D625F"/>
                 </a:solidFill>
@@ -16356,7 +16292,7 @@
         </p:nvSpPr>
         <p:spPr>
           <a:xfrm>
-            <a:off x="6553200" y="2914650"/>
+            <a:off x="6542809" y="2914650"/>
             <a:ext cx="4857750" cy="2476500"/>
           </a:xfrm>
           <a:prstGeom prst="rect">
@@ -16859,7 +16795,7 @@
         </p:nvSpPr>
         <p:spPr>
           <a:xfrm>
-            <a:off x="-6350" y="247650"/>
+            <a:off x="19051" y="247650"/>
             <a:ext cx="12192000" cy="6858000"/>
           </a:xfrm>
           <a:prstGeom prst="rect">
@@ -20878,70 +20814,6 @@
       </p:sp>
       <p:sp>
         <p:nvSpPr>
-          <p:cNvPr id="32" name="矩形 31">
-            <a:extLst>
-              <a:ext uri="{FF2B5EF4-FFF2-40B4-BE49-F238E27FC236}">
-                <a16:creationId xmlns:a16="http://schemas.microsoft.com/office/drawing/2014/main" id="{4BC358D9-0FFB-4451-A3CA-7BBAC9A18BC4}"/>
-              </a:ext>
-            </a:extLst>
-          </p:cNvPr>
-          <p:cNvSpPr>
-            <a:spLocks noGrp="1"/>
-          </p:cNvSpPr>
-          <p:nvPr/>
-        </p:nvSpPr>
-        <p:spPr>
-          <a:xfrm>
-            <a:off x="514350" y="6429375"/>
-            <a:ext cx="7810500" cy="171450"/>
-          </a:xfrm>
-          <a:prstGeom prst="rect">
-            <a:avLst/>
-          </a:prstGeom>
-          <a:solidFill>
-            <a:srgbClr val="000000">
-              <a:alpha val="0"/>
-            </a:srgbClr>
-          </a:solidFill>
-          <a:ln w="0">
-            <a:solidFill>
-              <a:srgbClr val="000000">
-                <a:alpha val="0"/>
-              </a:srgbClr>
-            </a:solidFill>
-            <a:prstDash val="solid"/>
-          </a:ln>
-        </p:spPr>
-        <p:txBody>
-          <a:bodyPr lIns="0" tIns="0" rIns="0" bIns="0" anchor="t"/>
-          <a:lstStyle/>
-          <a:p>
-            <a:pPr algn="l">
-              <a:defRPr sz="750" b="0">
-                <a:solidFill>
-                  <a:srgbClr val="5D625F"/>
-                </a:solidFill>
-                <a:latin typeface="Aptos"/>
-                <a:ea typeface="Aptos"/>
-                <a:cs typeface="Aptos"/>
-              </a:defRPr>
-            </a:pPr>
-            <a:r>
-              <a:rPr sz="750" b="0">
-                <a:solidFill>
-                  <a:srgbClr val="5D625F"/>
-                </a:solidFill>
-                <a:latin typeface="Aptos"/>
-                <a:ea typeface="Aptos"/>
-                <a:cs typeface="Aptos"/>
-              </a:rPr>
-              <a:t>Literature study defense | LLMs for software testing and fault localization</a:t>
-            </a:r>
-          </a:p>
-        </p:txBody>
-      </p:sp>
-      <p:sp>
-        <p:nvSpPr>
           <p:cNvPr id="33" name="矩形 32">
             <a:extLst>
               <a:ext uri="{FF2B5EF4-FFF2-40B4-BE49-F238E27FC236}">
@@ -21233,7 +21105,7 @@
               </a:defRPr>
             </a:pPr>
             <a:r>
-              <a:rPr sz="3150" b="1">
+              <a:rPr sz="3150" b="1" dirty="0">
                 <a:solidFill>
                   <a:srgbClr val="1F2328"/>
                 </a:solidFill>

</xml_diff>